<commit_message>
Revising the Mega2R paper.
</commit_message>
<xml_diff>
--- a/mega2_html/Article/Mega2Rfig1.pptx
+++ b/mega2_html/Article/Mega2Rfig1.pptx
@@ -1,20 +1,20 @@
 
 <file path=ppt/presentation.xml><?xml version="1.0" encoding="utf-8"?>
-<p:presentation xmlns:a="http://schemas.openxmlformats.org/drawingml/2006/main" xmlns:r="http://schemas.openxmlformats.org/officeDocument/2006/relationships" xmlns:mc="http://schemas.openxmlformats.org/markup-compatibility/2006" xmlns:mv="urn:schemas-microsoft-com:mac:vml" xmlns:p="http://schemas.openxmlformats.org/presentationml/2006/main" mc:Ignorable="mv" mc:PreserveAttributes="mv:*" saveSubsetFonts="1" autoCompressPictures="0">
+<p:presentation xmlns:a="http://schemas.openxmlformats.org/drawingml/2006/main" xmlns:r="http://schemas.openxmlformats.org/officeDocument/2006/relationships" xmlns:p="http://schemas.openxmlformats.org/presentationml/2006/main" saveSubsetFonts="1" autoCompressPictures="0">
   <p:sldMasterIdLst>
     <p:sldMasterId id="2147483648" r:id="rId1"/>
   </p:sldMasterIdLst>
   <p:sldIdLst>
     <p:sldId id="256" r:id="rId2"/>
   </p:sldIdLst>
-  <p:sldSz cx="9144000" cy="6858000" type="screen4x3"/>
+  <p:sldSz cx="3657600" cy="3657600"/>
   <p:notesSz cx="6858000" cy="9144000"/>
   <p:defaultTextStyle>
     <a:defPPr>
       <a:defRPr lang="en-US"/>
     </a:defPPr>
-    <a:lvl1pPr marL="0" algn="l" defTabSz="457200" rtl="0" eaLnBrk="1" latinLnBrk="0" hangingPunct="1">
-      <a:defRPr sz="1800" kern="1200">
+    <a:lvl1pPr marL="0" algn="l" defTabSz="261227" rtl="0" eaLnBrk="1" latinLnBrk="0" hangingPunct="1">
+      <a:defRPr sz="1100" kern="1200">
         <a:solidFill>
           <a:schemeClr val="tx1"/>
         </a:solidFill>
@@ -23,8 +23,8 @@
         <a:cs typeface="+mn-cs"/>
       </a:defRPr>
     </a:lvl1pPr>
-    <a:lvl2pPr marL="457200" algn="l" defTabSz="457200" rtl="0" eaLnBrk="1" latinLnBrk="0" hangingPunct="1">
-      <a:defRPr sz="1800" kern="1200">
+    <a:lvl2pPr marL="261227" algn="l" defTabSz="261227" rtl="0" eaLnBrk="1" latinLnBrk="0" hangingPunct="1">
+      <a:defRPr sz="1100" kern="1200">
         <a:solidFill>
           <a:schemeClr val="tx1"/>
         </a:solidFill>
@@ -33,8 +33,8 @@
         <a:cs typeface="+mn-cs"/>
       </a:defRPr>
     </a:lvl2pPr>
-    <a:lvl3pPr marL="914400" algn="l" defTabSz="457200" rtl="0" eaLnBrk="1" latinLnBrk="0" hangingPunct="1">
-      <a:defRPr sz="1800" kern="1200">
+    <a:lvl3pPr marL="522454" algn="l" defTabSz="261227" rtl="0" eaLnBrk="1" latinLnBrk="0" hangingPunct="1">
+      <a:defRPr sz="1100" kern="1200">
         <a:solidFill>
           <a:schemeClr val="tx1"/>
         </a:solidFill>
@@ -43,8 +43,8 @@
         <a:cs typeface="+mn-cs"/>
       </a:defRPr>
     </a:lvl3pPr>
-    <a:lvl4pPr marL="1371600" algn="l" defTabSz="457200" rtl="0" eaLnBrk="1" latinLnBrk="0" hangingPunct="1">
-      <a:defRPr sz="1800" kern="1200">
+    <a:lvl4pPr marL="783680" algn="l" defTabSz="261227" rtl="0" eaLnBrk="1" latinLnBrk="0" hangingPunct="1">
+      <a:defRPr sz="1100" kern="1200">
         <a:solidFill>
           <a:schemeClr val="tx1"/>
         </a:solidFill>
@@ -53,8 +53,8 @@
         <a:cs typeface="+mn-cs"/>
       </a:defRPr>
     </a:lvl4pPr>
-    <a:lvl5pPr marL="1828800" algn="l" defTabSz="457200" rtl="0" eaLnBrk="1" latinLnBrk="0" hangingPunct="1">
-      <a:defRPr sz="1800" kern="1200">
+    <a:lvl5pPr marL="1044909" algn="l" defTabSz="261227" rtl="0" eaLnBrk="1" latinLnBrk="0" hangingPunct="1">
+      <a:defRPr sz="1100" kern="1200">
         <a:solidFill>
           <a:schemeClr val="tx1"/>
         </a:solidFill>
@@ -63,8 +63,8 @@
         <a:cs typeface="+mn-cs"/>
       </a:defRPr>
     </a:lvl5pPr>
-    <a:lvl6pPr marL="2286000" algn="l" defTabSz="457200" rtl="0" eaLnBrk="1" latinLnBrk="0" hangingPunct="1">
-      <a:defRPr sz="1800" kern="1200">
+    <a:lvl6pPr marL="1306135" algn="l" defTabSz="261227" rtl="0" eaLnBrk="1" latinLnBrk="0" hangingPunct="1">
+      <a:defRPr sz="1100" kern="1200">
         <a:solidFill>
           <a:schemeClr val="tx1"/>
         </a:solidFill>
@@ -73,8 +73,8 @@
         <a:cs typeface="+mn-cs"/>
       </a:defRPr>
     </a:lvl6pPr>
-    <a:lvl7pPr marL="2743200" algn="l" defTabSz="457200" rtl="0" eaLnBrk="1" latinLnBrk="0" hangingPunct="1">
-      <a:defRPr sz="1800" kern="1200">
+    <a:lvl7pPr marL="1567362" algn="l" defTabSz="261227" rtl="0" eaLnBrk="1" latinLnBrk="0" hangingPunct="1">
+      <a:defRPr sz="1100" kern="1200">
         <a:solidFill>
           <a:schemeClr val="tx1"/>
         </a:solidFill>
@@ -83,8 +83,8 @@
         <a:cs typeface="+mn-cs"/>
       </a:defRPr>
     </a:lvl7pPr>
-    <a:lvl8pPr marL="3200400" algn="l" defTabSz="457200" rtl="0" eaLnBrk="1" latinLnBrk="0" hangingPunct="1">
-      <a:defRPr sz="1800" kern="1200">
+    <a:lvl8pPr marL="1828589" algn="l" defTabSz="261227" rtl="0" eaLnBrk="1" latinLnBrk="0" hangingPunct="1">
+      <a:defRPr sz="1100" kern="1200">
         <a:solidFill>
           <a:schemeClr val="tx1"/>
         </a:solidFill>
@@ -93,8 +93,8 @@
         <a:cs typeface="+mn-cs"/>
       </a:defRPr>
     </a:lvl8pPr>
-    <a:lvl9pPr marL="3657600" algn="l" defTabSz="457200" rtl="0" eaLnBrk="1" latinLnBrk="0" hangingPunct="1">
-      <a:defRPr sz="1800" kern="1200">
+    <a:lvl9pPr marL="2089818" algn="l" defTabSz="261227" rtl="0" eaLnBrk="1" latinLnBrk="0" hangingPunct="1">
+      <a:defRPr sz="1100" kern="1200">
         <a:solidFill>
           <a:schemeClr val="tx1"/>
         </a:solidFill>
@@ -108,7 +108,7 @@
 </file>
 
 <file path=ppt/slideLayouts/slideLayout1.xml><?xml version="1.0" encoding="utf-8"?>
-<p:sldLayout xmlns:a="http://schemas.openxmlformats.org/drawingml/2006/main" xmlns:r="http://schemas.openxmlformats.org/officeDocument/2006/relationships" xmlns:mc="http://schemas.openxmlformats.org/markup-compatibility/2006" xmlns:mv="urn:schemas-microsoft-com:mac:vml" xmlns:p="http://schemas.openxmlformats.org/presentationml/2006/main" mc:Ignorable="mv" mc:PreserveAttributes="mv:*" type="title" preserve="1">
+<p:sldLayout xmlns:a="http://schemas.openxmlformats.org/drawingml/2006/main" xmlns:r="http://schemas.openxmlformats.org/officeDocument/2006/relationships" xmlns:p="http://schemas.openxmlformats.org/presentationml/2006/main" type="title" preserve="1">
   <p:cSld name="Title Slide">
     <p:spTree>
       <p:nvGrpSpPr>
@@ -136,8 +136,8 @@
         </p:nvSpPr>
         <p:spPr>
           <a:xfrm>
-            <a:off x="685800" y="2130425"/>
-            <a:ext cx="7772400" cy="1470025"/>
+            <a:off x="274320" y="1136229"/>
+            <a:ext cx="3108960" cy="784015"/>
           </a:xfrm>
         </p:spPr>
         <p:txBody>
@@ -164,8 +164,8 @@
         </p:nvSpPr>
         <p:spPr>
           <a:xfrm>
-            <a:off x="1371600" y="3886200"/>
-            <a:ext cx="6400800" cy="1752600"/>
+            <a:off x="548640" y="2072640"/>
+            <a:ext cx="2560320" cy="934720"/>
           </a:xfrm>
         </p:spPr>
         <p:txBody>
@@ -181,7 +181,7 @@
                 </a:solidFill>
               </a:defRPr>
             </a:lvl1pPr>
-            <a:lvl2pPr marL="457200" indent="0" algn="ctr">
+            <a:lvl2pPr marL="261227" indent="0" algn="ctr">
               <a:buNone/>
               <a:defRPr>
                 <a:solidFill>
@@ -191,7 +191,7 @@
                 </a:solidFill>
               </a:defRPr>
             </a:lvl2pPr>
-            <a:lvl3pPr marL="914400" indent="0" algn="ctr">
+            <a:lvl3pPr marL="522454" indent="0" algn="ctr">
               <a:buNone/>
               <a:defRPr>
                 <a:solidFill>
@@ -201,7 +201,7 @@
                 </a:solidFill>
               </a:defRPr>
             </a:lvl3pPr>
-            <a:lvl4pPr marL="1371600" indent="0" algn="ctr">
+            <a:lvl4pPr marL="783680" indent="0" algn="ctr">
               <a:buNone/>
               <a:defRPr>
                 <a:solidFill>
@@ -211,7 +211,7 @@
                 </a:solidFill>
               </a:defRPr>
             </a:lvl4pPr>
-            <a:lvl5pPr marL="1828800" indent="0" algn="ctr">
+            <a:lvl5pPr marL="1044909" indent="0" algn="ctr">
               <a:buNone/>
               <a:defRPr>
                 <a:solidFill>
@@ -221,7 +221,7 @@
                 </a:solidFill>
               </a:defRPr>
             </a:lvl5pPr>
-            <a:lvl6pPr marL="2286000" indent="0" algn="ctr">
+            <a:lvl6pPr marL="1306135" indent="0" algn="ctr">
               <a:buNone/>
               <a:defRPr>
                 <a:solidFill>
@@ -231,7 +231,7 @@
                 </a:solidFill>
               </a:defRPr>
             </a:lvl6pPr>
-            <a:lvl7pPr marL="2743200" indent="0" algn="ctr">
+            <a:lvl7pPr marL="1567362" indent="0" algn="ctr">
               <a:buNone/>
               <a:defRPr>
                 <a:solidFill>
@@ -241,7 +241,7 @@
                 </a:solidFill>
               </a:defRPr>
             </a:lvl7pPr>
-            <a:lvl8pPr marL="3200400" indent="0" algn="ctr">
+            <a:lvl8pPr marL="1828589" indent="0" algn="ctr">
               <a:buNone/>
               <a:defRPr>
                 <a:solidFill>
@@ -251,7 +251,7 @@
                 </a:solidFill>
               </a:defRPr>
             </a:lvl8pPr>
-            <a:lvl9pPr marL="3657600" indent="0" algn="ctr">
+            <a:lvl9pPr marL="2089818" indent="0" algn="ctr">
               <a:buNone/>
               <a:defRPr>
                 <a:solidFill>
@@ -288,7 +288,7 @@
           <a:p>
             <a:fld id="{7AE4F870-186A-EB4F-9838-041FBD4EA0A4}" type="datetimeFigureOut">
               <a:rPr lang="en-US" smtClean="0"/>
-              <a:t>12/11/18</a:t>
+              <a:t>1/16/19</a:t>
             </a:fld>
             <a:endParaRPr lang="en-US"/>
           </a:p>
@@ -345,7 +345,7 @@
 </file>
 
 <file path=ppt/slideLayouts/slideLayout10.xml><?xml version="1.0" encoding="utf-8"?>
-<p:sldLayout xmlns:a="http://schemas.openxmlformats.org/drawingml/2006/main" xmlns:r="http://schemas.openxmlformats.org/officeDocument/2006/relationships" xmlns:mc="http://schemas.openxmlformats.org/markup-compatibility/2006" xmlns:mv="urn:schemas-microsoft-com:mac:vml" xmlns:p="http://schemas.openxmlformats.org/presentationml/2006/main" mc:Ignorable="mv" mc:PreserveAttributes="mv:*" type="vertTx" preserve="1">
+<p:sldLayout xmlns:a="http://schemas.openxmlformats.org/drawingml/2006/main" xmlns:r="http://schemas.openxmlformats.org/officeDocument/2006/relationships" xmlns:p="http://schemas.openxmlformats.org/presentationml/2006/main" type="vertTx" preserve="1">
   <p:cSld name="Title and Vertical Text">
     <p:spTree>
       <p:nvGrpSpPr>
@@ -453,7 +453,7 @@
           <a:p>
             <a:fld id="{7AE4F870-186A-EB4F-9838-041FBD4EA0A4}" type="datetimeFigureOut">
               <a:rPr lang="en-US" smtClean="0"/>
-              <a:t>12/11/18</a:t>
+              <a:t>1/16/19</a:t>
             </a:fld>
             <a:endParaRPr lang="en-US"/>
           </a:p>
@@ -510,7 +510,7 @@
 </file>
 
 <file path=ppt/slideLayouts/slideLayout11.xml><?xml version="1.0" encoding="utf-8"?>
-<p:sldLayout xmlns:a="http://schemas.openxmlformats.org/drawingml/2006/main" xmlns:r="http://schemas.openxmlformats.org/officeDocument/2006/relationships" xmlns:mc="http://schemas.openxmlformats.org/markup-compatibility/2006" xmlns:mv="urn:schemas-microsoft-com:mac:vml" xmlns:p="http://schemas.openxmlformats.org/presentationml/2006/main" mc:Ignorable="mv" mc:PreserveAttributes="mv:*" type="vertTitleAndTx" preserve="1">
+<p:sldLayout xmlns:a="http://schemas.openxmlformats.org/drawingml/2006/main" xmlns:r="http://schemas.openxmlformats.org/officeDocument/2006/relationships" xmlns:p="http://schemas.openxmlformats.org/presentationml/2006/main" type="vertTitleAndTx" preserve="1">
   <p:cSld name="Vertical Title and Text">
     <p:spTree>
       <p:nvGrpSpPr>
@@ -538,8 +538,8 @@
         </p:nvSpPr>
         <p:spPr>
           <a:xfrm>
-            <a:off x="6629400" y="274638"/>
-            <a:ext cx="2057400" cy="5851525"/>
+            <a:off x="2651760" y="146475"/>
+            <a:ext cx="822960" cy="3120815"/>
           </a:xfrm>
         </p:spPr>
         <p:txBody>
@@ -566,8 +566,8 @@
         </p:nvSpPr>
         <p:spPr>
           <a:xfrm>
-            <a:off x="457200" y="274638"/>
-            <a:ext cx="6019800" cy="5851525"/>
+            <a:off x="182880" y="146475"/>
+            <a:ext cx="2407920" cy="3120815"/>
           </a:xfrm>
         </p:spPr>
         <p:txBody>
@@ -628,7 +628,7 @@
           <a:p>
             <a:fld id="{7AE4F870-186A-EB4F-9838-041FBD4EA0A4}" type="datetimeFigureOut">
               <a:rPr lang="en-US" smtClean="0"/>
-              <a:t>12/11/18</a:t>
+              <a:t>1/16/19</a:t>
             </a:fld>
             <a:endParaRPr lang="en-US"/>
           </a:p>
@@ -685,7 +685,7 @@
 </file>
 
 <file path=ppt/slideLayouts/slideLayout2.xml><?xml version="1.0" encoding="utf-8"?>
-<p:sldLayout xmlns:a="http://schemas.openxmlformats.org/drawingml/2006/main" xmlns:r="http://schemas.openxmlformats.org/officeDocument/2006/relationships" xmlns:mc="http://schemas.openxmlformats.org/markup-compatibility/2006" xmlns:mv="urn:schemas-microsoft-com:mac:vml" xmlns:p="http://schemas.openxmlformats.org/presentationml/2006/main" mc:Ignorable="mv" mc:PreserveAttributes="mv:*" type="obj" preserve="1">
+<p:sldLayout xmlns:a="http://schemas.openxmlformats.org/drawingml/2006/main" xmlns:r="http://schemas.openxmlformats.org/officeDocument/2006/relationships" xmlns:p="http://schemas.openxmlformats.org/presentationml/2006/main" type="obj" preserve="1">
   <p:cSld name="Title and Content">
     <p:spTree>
       <p:nvGrpSpPr>
@@ -793,7 +793,7 @@
           <a:p>
             <a:fld id="{7AE4F870-186A-EB4F-9838-041FBD4EA0A4}" type="datetimeFigureOut">
               <a:rPr lang="en-US" smtClean="0"/>
-              <a:t>12/11/18</a:t>
+              <a:t>1/16/19</a:t>
             </a:fld>
             <a:endParaRPr lang="en-US"/>
           </a:p>
@@ -850,7 +850,7 @@
 </file>
 
 <file path=ppt/slideLayouts/slideLayout3.xml><?xml version="1.0" encoding="utf-8"?>
-<p:sldLayout xmlns:a="http://schemas.openxmlformats.org/drawingml/2006/main" xmlns:r="http://schemas.openxmlformats.org/officeDocument/2006/relationships" xmlns:mc="http://schemas.openxmlformats.org/markup-compatibility/2006" xmlns:mv="urn:schemas-microsoft-com:mac:vml" xmlns:p="http://schemas.openxmlformats.org/presentationml/2006/main" mc:Ignorable="mv" mc:PreserveAttributes="mv:*" type="secHead" preserve="1">
+<p:sldLayout xmlns:a="http://schemas.openxmlformats.org/drawingml/2006/main" xmlns:r="http://schemas.openxmlformats.org/officeDocument/2006/relationships" xmlns:p="http://schemas.openxmlformats.org/presentationml/2006/main" type="secHead" preserve="1">
   <p:cSld name="Section Header">
     <p:spTree>
       <p:nvGrpSpPr>
@@ -878,15 +878,15 @@
         </p:nvSpPr>
         <p:spPr>
           <a:xfrm>
-            <a:off x="722313" y="4406900"/>
-            <a:ext cx="7772400" cy="1362075"/>
+            <a:off x="288927" y="2350345"/>
+            <a:ext cx="3108960" cy="726440"/>
           </a:xfrm>
         </p:spPr>
         <p:txBody>
           <a:bodyPr anchor="t"/>
           <a:lstStyle>
             <a:lvl1pPr algn="l">
-              <a:defRPr sz="4000" b="1" cap="all"/>
+              <a:defRPr sz="2300" b="1" cap="all"/>
             </a:lvl1pPr>
           </a:lstStyle>
           <a:p>
@@ -910,8 +910,8 @@
         </p:nvSpPr>
         <p:spPr>
           <a:xfrm>
-            <a:off x="722313" y="2906713"/>
-            <a:ext cx="7772400" cy="1500187"/>
+            <a:off x="288927" y="1550251"/>
+            <a:ext cx="3108960" cy="800100"/>
           </a:xfrm>
         </p:spPr>
         <p:txBody>
@@ -919,7 +919,7 @@
           <a:lstStyle>
             <a:lvl1pPr marL="0" indent="0">
               <a:buNone/>
-              <a:defRPr sz="2000">
+              <a:defRPr sz="1200">
                 <a:solidFill>
                   <a:schemeClr val="tx1">
                     <a:tint val="75000"/>
@@ -927,9 +927,9 @@
                 </a:solidFill>
               </a:defRPr>
             </a:lvl1pPr>
-            <a:lvl2pPr marL="457200" indent="0">
-              <a:buNone/>
-              <a:defRPr sz="1800">
+            <a:lvl2pPr marL="261227" indent="0">
+              <a:buNone/>
+              <a:defRPr sz="1100">
                 <a:solidFill>
                   <a:schemeClr val="tx1">
                     <a:tint val="75000"/>
@@ -937,9 +937,9 @@
                 </a:solidFill>
               </a:defRPr>
             </a:lvl2pPr>
-            <a:lvl3pPr marL="914400" indent="0">
-              <a:buNone/>
-              <a:defRPr sz="1600">
+            <a:lvl3pPr marL="522454" indent="0">
+              <a:buNone/>
+              <a:defRPr sz="800">
                 <a:solidFill>
                   <a:schemeClr val="tx1">
                     <a:tint val="75000"/>
@@ -947,9 +947,9 @@
                 </a:solidFill>
               </a:defRPr>
             </a:lvl3pPr>
-            <a:lvl4pPr marL="1371600" indent="0">
-              <a:buNone/>
-              <a:defRPr sz="1400">
+            <a:lvl4pPr marL="783680" indent="0">
+              <a:buNone/>
+              <a:defRPr sz="800">
                 <a:solidFill>
                   <a:schemeClr val="tx1">
                     <a:tint val="75000"/>
@@ -957,9 +957,9 @@
                 </a:solidFill>
               </a:defRPr>
             </a:lvl4pPr>
-            <a:lvl5pPr marL="1828800" indent="0">
-              <a:buNone/>
-              <a:defRPr sz="1400">
+            <a:lvl5pPr marL="1044909" indent="0">
+              <a:buNone/>
+              <a:defRPr sz="800">
                 <a:solidFill>
                   <a:schemeClr val="tx1">
                     <a:tint val="75000"/>
@@ -967,9 +967,9 @@
                 </a:solidFill>
               </a:defRPr>
             </a:lvl5pPr>
-            <a:lvl6pPr marL="2286000" indent="0">
-              <a:buNone/>
-              <a:defRPr sz="1400">
+            <a:lvl6pPr marL="1306135" indent="0">
+              <a:buNone/>
+              <a:defRPr sz="800">
                 <a:solidFill>
                   <a:schemeClr val="tx1">
                     <a:tint val="75000"/>
@@ -977,9 +977,9 @@
                 </a:solidFill>
               </a:defRPr>
             </a:lvl6pPr>
-            <a:lvl7pPr marL="2743200" indent="0">
-              <a:buNone/>
-              <a:defRPr sz="1400">
+            <a:lvl7pPr marL="1567362" indent="0">
+              <a:buNone/>
+              <a:defRPr sz="800">
                 <a:solidFill>
                   <a:schemeClr val="tx1">
                     <a:tint val="75000"/>
@@ -987,9 +987,9 @@
                 </a:solidFill>
               </a:defRPr>
             </a:lvl7pPr>
-            <a:lvl8pPr marL="3200400" indent="0">
-              <a:buNone/>
-              <a:defRPr sz="1400">
+            <a:lvl8pPr marL="1828589" indent="0">
+              <a:buNone/>
+              <a:defRPr sz="800">
                 <a:solidFill>
                   <a:schemeClr val="tx1">
                     <a:tint val="75000"/>
@@ -997,9 +997,9 @@
                 </a:solidFill>
               </a:defRPr>
             </a:lvl8pPr>
-            <a:lvl9pPr marL="3657600" indent="0">
-              <a:buNone/>
-              <a:defRPr sz="1400">
+            <a:lvl9pPr marL="2089818" indent="0">
+              <a:buNone/>
+              <a:defRPr sz="800">
                 <a:solidFill>
                   <a:schemeClr val="tx1">
                     <a:tint val="75000"/>
@@ -1034,7 +1034,7 @@
           <a:p>
             <a:fld id="{7AE4F870-186A-EB4F-9838-041FBD4EA0A4}" type="datetimeFigureOut">
               <a:rPr lang="en-US" smtClean="0"/>
-              <a:t>12/11/18</a:t>
+              <a:t>1/16/19</a:t>
             </a:fld>
             <a:endParaRPr lang="en-US"/>
           </a:p>
@@ -1091,7 +1091,7 @@
 </file>
 
 <file path=ppt/slideLayouts/slideLayout4.xml><?xml version="1.0" encoding="utf-8"?>
-<p:sldLayout xmlns:a="http://schemas.openxmlformats.org/drawingml/2006/main" xmlns:r="http://schemas.openxmlformats.org/officeDocument/2006/relationships" xmlns:mc="http://schemas.openxmlformats.org/markup-compatibility/2006" xmlns:mv="urn:schemas-microsoft-com:mac:vml" xmlns:p="http://schemas.openxmlformats.org/presentationml/2006/main" mc:Ignorable="mv" mc:PreserveAttributes="mv:*" type="twoObj" preserve="1">
+<p:sldLayout xmlns:a="http://schemas.openxmlformats.org/drawingml/2006/main" xmlns:r="http://schemas.openxmlformats.org/officeDocument/2006/relationships" xmlns:p="http://schemas.openxmlformats.org/presentationml/2006/main" type="twoObj" preserve="1">
   <p:cSld name="Two Content">
     <p:spTree>
       <p:nvGrpSpPr>
@@ -1142,39 +1142,39 @@
         </p:nvSpPr>
         <p:spPr>
           <a:xfrm>
-            <a:off x="457200" y="1600200"/>
-            <a:ext cx="4038600" cy="4525963"/>
+            <a:off x="182880" y="853443"/>
+            <a:ext cx="1615440" cy="2413847"/>
           </a:xfrm>
         </p:spPr>
         <p:txBody>
           <a:bodyPr/>
           <a:lstStyle>
             <a:lvl1pPr>
-              <a:defRPr sz="2800"/>
+              <a:defRPr sz="1700"/>
             </a:lvl1pPr>
             <a:lvl2pPr>
-              <a:defRPr sz="2400"/>
+              <a:defRPr sz="1300"/>
             </a:lvl2pPr>
             <a:lvl3pPr>
-              <a:defRPr sz="2000"/>
+              <a:defRPr sz="1200"/>
             </a:lvl3pPr>
             <a:lvl4pPr>
-              <a:defRPr sz="1800"/>
+              <a:defRPr sz="1100"/>
             </a:lvl4pPr>
             <a:lvl5pPr>
-              <a:defRPr sz="1800"/>
+              <a:defRPr sz="1100"/>
             </a:lvl5pPr>
             <a:lvl6pPr>
-              <a:defRPr sz="1800"/>
+              <a:defRPr sz="1100"/>
             </a:lvl6pPr>
             <a:lvl7pPr>
-              <a:defRPr sz="1800"/>
+              <a:defRPr sz="1100"/>
             </a:lvl7pPr>
             <a:lvl8pPr>
-              <a:defRPr sz="1800"/>
+              <a:defRPr sz="1100"/>
             </a:lvl8pPr>
             <a:lvl9pPr>
-              <a:defRPr sz="1800"/>
+              <a:defRPr sz="1100"/>
             </a:lvl9pPr>
           </a:lstStyle>
           <a:p>
@@ -1227,39 +1227,39 @@
         </p:nvSpPr>
         <p:spPr>
           <a:xfrm>
-            <a:off x="4648200" y="1600200"/>
-            <a:ext cx="4038600" cy="4525963"/>
+            <a:off x="1859280" y="853443"/>
+            <a:ext cx="1615440" cy="2413847"/>
           </a:xfrm>
         </p:spPr>
         <p:txBody>
           <a:bodyPr/>
           <a:lstStyle>
             <a:lvl1pPr>
-              <a:defRPr sz="2800"/>
+              <a:defRPr sz="1700"/>
             </a:lvl1pPr>
             <a:lvl2pPr>
-              <a:defRPr sz="2400"/>
+              <a:defRPr sz="1300"/>
             </a:lvl2pPr>
             <a:lvl3pPr>
-              <a:defRPr sz="2000"/>
+              <a:defRPr sz="1200"/>
             </a:lvl3pPr>
             <a:lvl4pPr>
-              <a:defRPr sz="1800"/>
+              <a:defRPr sz="1100"/>
             </a:lvl4pPr>
             <a:lvl5pPr>
-              <a:defRPr sz="1800"/>
+              <a:defRPr sz="1100"/>
             </a:lvl5pPr>
             <a:lvl6pPr>
-              <a:defRPr sz="1800"/>
+              <a:defRPr sz="1100"/>
             </a:lvl6pPr>
             <a:lvl7pPr>
-              <a:defRPr sz="1800"/>
+              <a:defRPr sz="1100"/>
             </a:lvl7pPr>
             <a:lvl8pPr>
-              <a:defRPr sz="1800"/>
+              <a:defRPr sz="1100"/>
             </a:lvl8pPr>
             <a:lvl9pPr>
-              <a:defRPr sz="1800"/>
+              <a:defRPr sz="1100"/>
             </a:lvl9pPr>
           </a:lstStyle>
           <a:p>
@@ -1317,7 +1317,7 @@
           <a:p>
             <a:fld id="{7AE4F870-186A-EB4F-9838-041FBD4EA0A4}" type="datetimeFigureOut">
               <a:rPr lang="en-US" smtClean="0"/>
-              <a:t>12/11/18</a:t>
+              <a:t>1/16/19</a:t>
             </a:fld>
             <a:endParaRPr lang="en-US"/>
           </a:p>
@@ -1374,7 +1374,7 @@
 </file>
 
 <file path=ppt/slideLayouts/slideLayout5.xml><?xml version="1.0" encoding="utf-8"?>
-<p:sldLayout xmlns:a="http://schemas.openxmlformats.org/drawingml/2006/main" xmlns:r="http://schemas.openxmlformats.org/officeDocument/2006/relationships" xmlns:mc="http://schemas.openxmlformats.org/markup-compatibility/2006" xmlns:mv="urn:schemas-microsoft-com:mac:vml" xmlns:p="http://schemas.openxmlformats.org/presentationml/2006/main" mc:Ignorable="mv" mc:PreserveAttributes="mv:*" type="twoTxTwoObj" preserve="1">
+<p:sldLayout xmlns:a="http://schemas.openxmlformats.org/drawingml/2006/main" xmlns:r="http://schemas.openxmlformats.org/officeDocument/2006/relationships" xmlns:p="http://schemas.openxmlformats.org/presentationml/2006/main" type="twoTxTwoObj" preserve="1">
   <p:cSld name="Comparison">
     <p:spTree>
       <p:nvGrpSpPr>
@@ -1429,8 +1429,8 @@
         </p:nvSpPr>
         <p:spPr>
           <a:xfrm>
-            <a:off x="457200" y="1535113"/>
-            <a:ext cx="4040188" cy="639762"/>
+            <a:off x="182881" y="818727"/>
+            <a:ext cx="1616075" cy="341207"/>
           </a:xfrm>
         </p:spPr>
         <p:txBody>
@@ -1438,39 +1438,39 @@
           <a:lstStyle>
             <a:lvl1pPr marL="0" indent="0">
               <a:buNone/>
-              <a:defRPr sz="2400" b="1"/>
+              <a:defRPr sz="1300" b="1"/>
             </a:lvl1pPr>
-            <a:lvl2pPr marL="457200" indent="0">
-              <a:buNone/>
-              <a:defRPr sz="2000" b="1"/>
+            <a:lvl2pPr marL="261227" indent="0">
+              <a:buNone/>
+              <a:defRPr sz="1200" b="1"/>
             </a:lvl2pPr>
-            <a:lvl3pPr marL="914400" indent="0">
-              <a:buNone/>
-              <a:defRPr sz="1800" b="1"/>
+            <a:lvl3pPr marL="522454" indent="0">
+              <a:buNone/>
+              <a:defRPr sz="1100" b="1"/>
             </a:lvl3pPr>
-            <a:lvl4pPr marL="1371600" indent="0">
-              <a:buNone/>
-              <a:defRPr sz="1600" b="1"/>
+            <a:lvl4pPr marL="783680" indent="0">
+              <a:buNone/>
+              <a:defRPr sz="800" b="1"/>
             </a:lvl4pPr>
-            <a:lvl5pPr marL="1828800" indent="0">
-              <a:buNone/>
-              <a:defRPr sz="1600" b="1"/>
+            <a:lvl5pPr marL="1044909" indent="0">
+              <a:buNone/>
+              <a:defRPr sz="800" b="1"/>
             </a:lvl5pPr>
-            <a:lvl6pPr marL="2286000" indent="0">
-              <a:buNone/>
-              <a:defRPr sz="1600" b="1"/>
+            <a:lvl6pPr marL="1306135" indent="0">
+              <a:buNone/>
+              <a:defRPr sz="800" b="1"/>
             </a:lvl6pPr>
-            <a:lvl7pPr marL="2743200" indent="0">
-              <a:buNone/>
-              <a:defRPr sz="1600" b="1"/>
+            <a:lvl7pPr marL="1567362" indent="0">
+              <a:buNone/>
+              <a:defRPr sz="800" b="1"/>
             </a:lvl7pPr>
-            <a:lvl8pPr marL="3200400" indent="0">
-              <a:buNone/>
-              <a:defRPr sz="1600" b="1"/>
+            <a:lvl8pPr marL="1828589" indent="0">
+              <a:buNone/>
+              <a:defRPr sz="800" b="1"/>
             </a:lvl8pPr>
-            <a:lvl9pPr marL="3657600" indent="0">
-              <a:buNone/>
-              <a:defRPr sz="1600" b="1"/>
+            <a:lvl9pPr marL="2089818" indent="0">
+              <a:buNone/>
+              <a:defRPr sz="800" b="1"/>
             </a:lvl9pPr>
           </a:lstStyle>
           <a:p>
@@ -1494,39 +1494,39 @@
         </p:nvSpPr>
         <p:spPr>
           <a:xfrm>
-            <a:off x="457200" y="2174875"/>
-            <a:ext cx="4040188" cy="3951288"/>
+            <a:off x="182881" y="1159933"/>
+            <a:ext cx="1616075" cy="2107355"/>
           </a:xfrm>
         </p:spPr>
         <p:txBody>
           <a:bodyPr/>
           <a:lstStyle>
             <a:lvl1pPr>
-              <a:defRPr sz="2400"/>
+              <a:defRPr sz="1300"/>
             </a:lvl1pPr>
             <a:lvl2pPr>
-              <a:defRPr sz="2000"/>
+              <a:defRPr sz="1200"/>
             </a:lvl2pPr>
             <a:lvl3pPr>
-              <a:defRPr sz="1800"/>
+              <a:defRPr sz="1100"/>
             </a:lvl3pPr>
             <a:lvl4pPr>
-              <a:defRPr sz="1600"/>
+              <a:defRPr sz="800"/>
             </a:lvl4pPr>
             <a:lvl5pPr>
-              <a:defRPr sz="1600"/>
+              <a:defRPr sz="800"/>
             </a:lvl5pPr>
             <a:lvl6pPr>
-              <a:defRPr sz="1600"/>
+              <a:defRPr sz="800"/>
             </a:lvl6pPr>
             <a:lvl7pPr>
-              <a:defRPr sz="1600"/>
+              <a:defRPr sz="800"/>
             </a:lvl7pPr>
             <a:lvl8pPr>
-              <a:defRPr sz="1600"/>
+              <a:defRPr sz="800"/>
             </a:lvl8pPr>
             <a:lvl9pPr>
-              <a:defRPr sz="1600"/>
+              <a:defRPr sz="800"/>
             </a:lvl9pPr>
           </a:lstStyle>
           <a:p>
@@ -1579,8 +1579,8 @@
         </p:nvSpPr>
         <p:spPr>
           <a:xfrm>
-            <a:off x="4645025" y="1535113"/>
-            <a:ext cx="4041775" cy="639762"/>
+            <a:off x="1858011" y="818727"/>
+            <a:ext cx="1616711" cy="341207"/>
           </a:xfrm>
         </p:spPr>
         <p:txBody>
@@ -1588,39 +1588,39 @@
           <a:lstStyle>
             <a:lvl1pPr marL="0" indent="0">
               <a:buNone/>
-              <a:defRPr sz="2400" b="1"/>
+              <a:defRPr sz="1300" b="1"/>
             </a:lvl1pPr>
-            <a:lvl2pPr marL="457200" indent="0">
-              <a:buNone/>
-              <a:defRPr sz="2000" b="1"/>
+            <a:lvl2pPr marL="261227" indent="0">
+              <a:buNone/>
+              <a:defRPr sz="1200" b="1"/>
             </a:lvl2pPr>
-            <a:lvl3pPr marL="914400" indent="0">
-              <a:buNone/>
-              <a:defRPr sz="1800" b="1"/>
+            <a:lvl3pPr marL="522454" indent="0">
+              <a:buNone/>
+              <a:defRPr sz="1100" b="1"/>
             </a:lvl3pPr>
-            <a:lvl4pPr marL="1371600" indent="0">
-              <a:buNone/>
-              <a:defRPr sz="1600" b="1"/>
+            <a:lvl4pPr marL="783680" indent="0">
+              <a:buNone/>
+              <a:defRPr sz="800" b="1"/>
             </a:lvl4pPr>
-            <a:lvl5pPr marL="1828800" indent="0">
-              <a:buNone/>
-              <a:defRPr sz="1600" b="1"/>
+            <a:lvl5pPr marL="1044909" indent="0">
+              <a:buNone/>
+              <a:defRPr sz="800" b="1"/>
             </a:lvl5pPr>
-            <a:lvl6pPr marL="2286000" indent="0">
-              <a:buNone/>
-              <a:defRPr sz="1600" b="1"/>
+            <a:lvl6pPr marL="1306135" indent="0">
+              <a:buNone/>
+              <a:defRPr sz="800" b="1"/>
             </a:lvl6pPr>
-            <a:lvl7pPr marL="2743200" indent="0">
-              <a:buNone/>
-              <a:defRPr sz="1600" b="1"/>
+            <a:lvl7pPr marL="1567362" indent="0">
+              <a:buNone/>
+              <a:defRPr sz="800" b="1"/>
             </a:lvl7pPr>
-            <a:lvl8pPr marL="3200400" indent="0">
-              <a:buNone/>
-              <a:defRPr sz="1600" b="1"/>
+            <a:lvl8pPr marL="1828589" indent="0">
+              <a:buNone/>
+              <a:defRPr sz="800" b="1"/>
             </a:lvl8pPr>
-            <a:lvl9pPr marL="3657600" indent="0">
-              <a:buNone/>
-              <a:defRPr sz="1600" b="1"/>
+            <a:lvl9pPr marL="2089818" indent="0">
+              <a:buNone/>
+              <a:defRPr sz="800" b="1"/>
             </a:lvl9pPr>
           </a:lstStyle>
           <a:p>
@@ -1644,39 +1644,39 @@
         </p:nvSpPr>
         <p:spPr>
           <a:xfrm>
-            <a:off x="4645025" y="2174875"/>
-            <a:ext cx="4041775" cy="3951288"/>
+            <a:off x="1858011" y="1159933"/>
+            <a:ext cx="1616711" cy="2107355"/>
           </a:xfrm>
         </p:spPr>
         <p:txBody>
           <a:bodyPr/>
           <a:lstStyle>
             <a:lvl1pPr>
-              <a:defRPr sz="2400"/>
+              <a:defRPr sz="1300"/>
             </a:lvl1pPr>
             <a:lvl2pPr>
-              <a:defRPr sz="2000"/>
+              <a:defRPr sz="1200"/>
             </a:lvl2pPr>
             <a:lvl3pPr>
-              <a:defRPr sz="1800"/>
+              <a:defRPr sz="1100"/>
             </a:lvl3pPr>
             <a:lvl4pPr>
-              <a:defRPr sz="1600"/>
+              <a:defRPr sz="800"/>
             </a:lvl4pPr>
             <a:lvl5pPr>
-              <a:defRPr sz="1600"/>
+              <a:defRPr sz="800"/>
             </a:lvl5pPr>
             <a:lvl6pPr>
-              <a:defRPr sz="1600"/>
+              <a:defRPr sz="800"/>
             </a:lvl6pPr>
             <a:lvl7pPr>
-              <a:defRPr sz="1600"/>
+              <a:defRPr sz="800"/>
             </a:lvl7pPr>
             <a:lvl8pPr>
-              <a:defRPr sz="1600"/>
+              <a:defRPr sz="800"/>
             </a:lvl8pPr>
             <a:lvl9pPr>
-              <a:defRPr sz="1600"/>
+              <a:defRPr sz="800"/>
             </a:lvl9pPr>
           </a:lstStyle>
           <a:p>
@@ -1734,7 +1734,7 @@
           <a:p>
             <a:fld id="{7AE4F870-186A-EB4F-9838-041FBD4EA0A4}" type="datetimeFigureOut">
               <a:rPr lang="en-US" smtClean="0"/>
-              <a:t>12/11/18</a:t>
+              <a:t>1/16/19</a:t>
             </a:fld>
             <a:endParaRPr lang="en-US"/>
           </a:p>
@@ -1791,7 +1791,7 @@
 </file>
 
 <file path=ppt/slideLayouts/slideLayout6.xml><?xml version="1.0" encoding="utf-8"?>
-<p:sldLayout xmlns:a="http://schemas.openxmlformats.org/drawingml/2006/main" xmlns:r="http://schemas.openxmlformats.org/officeDocument/2006/relationships" xmlns:mc="http://schemas.openxmlformats.org/markup-compatibility/2006" xmlns:mv="urn:schemas-microsoft-com:mac:vml" xmlns:p="http://schemas.openxmlformats.org/presentationml/2006/main" mc:Ignorable="mv" mc:PreserveAttributes="mv:*" type="titleOnly" preserve="1">
+<p:sldLayout xmlns:a="http://schemas.openxmlformats.org/drawingml/2006/main" xmlns:r="http://schemas.openxmlformats.org/officeDocument/2006/relationships" xmlns:p="http://schemas.openxmlformats.org/presentationml/2006/main" type="titleOnly" preserve="1">
   <p:cSld name="Title Only">
     <p:spTree>
       <p:nvGrpSpPr>
@@ -1847,7 +1847,7 @@
           <a:p>
             <a:fld id="{7AE4F870-186A-EB4F-9838-041FBD4EA0A4}" type="datetimeFigureOut">
               <a:rPr lang="en-US" smtClean="0"/>
-              <a:t>12/11/18</a:t>
+              <a:t>1/16/19</a:t>
             </a:fld>
             <a:endParaRPr lang="en-US"/>
           </a:p>
@@ -1904,7 +1904,7 @@
 </file>
 
 <file path=ppt/slideLayouts/slideLayout7.xml><?xml version="1.0" encoding="utf-8"?>
-<p:sldLayout xmlns:a="http://schemas.openxmlformats.org/drawingml/2006/main" xmlns:r="http://schemas.openxmlformats.org/officeDocument/2006/relationships" xmlns:mc="http://schemas.openxmlformats.org/markup-compatibility/2006" xmlns:mv="urn:schemas-microsoft-com:mac:vml" xmlns:p="http://schemas.openxmlformats.org/presentationml/2006/main" mc:Ignorable="mv" mc:PreserveAttributes="mv:*" type="blank" preserve="1">
+<p:sldLayout xmlns:a="http://schemas.openxmlformats.org/drawingml/2006/main" xmlns:r="http://schemas.openxmlformats.org/officeDocument/2006/relationships" xmlns:p="http://schemas.openxmlformats.org/presentationml/2006/main" type="blank" preserve="1">
   <p:cSld name="Blank">
     <p:spTree>
       <p:nvGrpSpPr>
@@ -1937,7 +1937,7 @@
           <a:p>
             <a:fld id="{7AE4F870-186A-EB4F-9838-041FBD4EA0A4}" type="datetimeFigureOut">
               <a:rPr lang="en-US" smtClean="0"/>
-              <a:t>12/11/18</a:t>
+              <a:t>1/16/19</a:t>
             </a:fld>
             <a:endParaRPr lang="en-US"/>
           </a:p>
@@ -1994,7 +1994,7 @@
 </file>
 
 <file path=ppt/slideLayouts/slideLayout8.xml><?xml version="1.0" encoding="utf-8"?>
-<p:sldLayout xmlns:a="http://schemas.openxmlformats.org/drawingml/2006/main" xmlns:r="http://schemas.openxmlformats.org/officeDocument/2006/relationships" xmlns:mc="http://schemas.openxmlformats.org/markup-compatibility/2006" xmlns:mv="urn:schemas-microsoft-com:mac:vml" xmlns:p="http://schemas.openxmlformats.org/presentationml/2006/main" mc:Ignorable="mv" mc:PreserveAttributes="mv:*" type="objTx" preserve="1">
+<p:sldLayout xmlns:a="http://schemas.openxmlformats.org/drawingml/2006/main" xmlns:r="http://schemas.openxmlformats.org/officeDocument/2006/relationships" xmlns:p="http://schemas.openxmlformats.org/presentationml/2006/main" type="objTx" preserve="1">
   <p:cSld name="Content with Caption">
     <p:spTree>
       <p:nvGrpSpPr>
@@ -2022,15 +2022,15 @@
         </p:nvSpPr>
         <p:spPr>
           <a:xfrm>
-            <a:off x="457200" y="273050"/>
-            <a:ext cx="3008313" cy="1162050"/>
+            <a:off x="182882" y="145627"/>
+            <a:ext cx="1203327" cy="619760"/>
           </a:xfrm>
         </p:spPr>
         <p:txBody>
           <a:bodyPr anchor="b"/>
           <a:lstStyle>
             <a:lvl1pPr algn="l">
-              <a:defRPr sz="2000" b="1"/>
+              <a:defRPr sz="1200" b="1"/>
             </a:lvl1pPr>
           </a:lstStyle>
           <a:p>
@@ -2054,39 +2054,39 @@
         </p:nvSpPr>
         <p:spPr>
           <a:xfrm>
-            <a:off x="3575050" y="273050"/>
-            <a:ext cx="5111750" cy="5853113"/>
+            <a:off x="1430023" y="145631"/>
+            <a:ext cx="2044700" cy="3121660"/>
           </a:xfrm>
         </p:spPr>
         <p:txBody>
           <a:bodyPr/>
           <a:lstStyle>
             <a:lvl1pPr>
-              <a:defRPr sz="3200"/>
+              <a:defRPr sz="1900"/>
             </a:lvl1pPr>
             <a:lvl2pPr>
-              <a:defRPr sz="2800"/>
+              <a:defRPr sz="1700"/>
             </a:lvl2pPr>
             <a:lvl3pPr>
-              <a:defRPr sz="2400"/>
+              <a:defRPr sz="1300"/>
             </a:lvl3pPr>
             <a:lvl4pPr>
-              <a:defRPr sz="2000"/>
+              <a:defRPr sz="1200"/>
             </a:lvl4pPr>
             <a:lvl5pPr>
-              <a:defRPr sz="2000"/>
+              <a:defRPr sz="1200"/>
             </a:lvl5pPr>
             <a:lvl6pPr>
-              <a:defRPr sz="2000"/>
+              <a:defRPr sz="1200"/>
             </a:lvl6pPr>
             <a:lvl7pPr>
-              <a:defRPr sz="2000"/>
+              <a:defRPr sz="1200"/>
             </a:lvl7pPr>
             <a:lvl8pPr>
-              <a:defRPr sz="2000"/>
+              <a:defRPr sz="1200"/>
             </a:lvl8pPr>
             <a:lvl9pPr>
-              <a:defRPr sz="2000"/>
+              <a:defRPr sz="1200"/>
             </a:lvl9pPr>
           </a:lstStyle>
           <a:p>
@@ -2139,8 +2139,8 @@
         </p:nvSpPr>
         <p:spPr>
           <a:xfrm>
-            <a:off x="457200" y="1435100"/>
-            <a:ext cx="3008313" cy="4691063"/>
+            <a:off x="182882" y="765391"/>
+            <a:ext cx="1203327" cy="2501900"/>
           </a:xfrm>
         </p:spPr>
         <p:txBody>
@@ -2148,39 +2148,39 @@
           <a:lstStyle>
             <a:lvl1pPr marL="0" indent="0">
               <a:buNone/>
-              <a:defRPr sz="1400"/>
+              <a:defRPr sz="800"/>
             </a:lvl1pPr>
-            <a:lvl2pPr marL="457200" indent="0">
-              <a:buNone/>
-              <a:defRPr sz="1200"/>
+            <a:lvl2pPr marL="261227" indent="0">
+              <a:buNone/>
+              <a:defRPr sz="700"/>
             </a:lvl2pPr>
-            <a:lvl3pPr marL="914400" indent="0">
-              <a:buNone/>
-              <a:defRPr sz="1000"/>
+            <a:lvl3pPr marL="522454" indent="0">
+              <a:buNone/>
+              <a:defRPr sz="700"/>
             </a:lvl3pPr>
-            <a:lvl4pPr marL="1371600" indent="0">
-              <a:buNone/>
-              <a:defRPr sz="900"/>
+            <a:lvl4pPr marL="783680" indent="0">
+              <a:buNone/>
+              <a:defRPr sz="500"/>
             </a:lvl4pPr>
-            <a:lvl5pPr marL="1828800" indent="0">
-              <a:buNone/>
-              <a:defRPr sz="900"/>
+            <a:lvl5pPr marL="1044909" indent="0">
+              <a:buNone/>
+              <a:defRPr sz="500"/>
             </a:lvl5pPr>
-            <a:lvl6pPr marL="2286000" indent="0">
-              <a:buNone/>
-              <a:defRPr sz="900"/>
+            <a:lvl6pPr marL="1306135" indent="0">
+              <a:buNone/>
+              <a:defRPr sz="500"/>
             </a:lvl6pPr>
-            <a:lvl7pPr marL="2743200" indent="0">
-              <a:buNone/>
-              <a:defRPr sz="900"/>
+            <a:lvl7pPr marL="1567362" indent="0">
+              <a:buNone/>
+              <a:defRPr sz="500"/>
             </a:lvl7pPr>
-            <a:lvl8pPr marL="3200400" indent="0">
-              <a:buNone/>
-              <a:defRPr sz="900"/>
+            <a:lvl8pPr marL="1828589" indent="0">
+              <a:buNone/>
+              <a:defRPr sz="500"/>
             </a:lvl8pPr>
-            <a:lvl9pPr marL="3657600" indent="0">
-              <a:buNone/>
-              <a:defRPr sz="900"/>
+            <a:lvl9pPr marL="2089818" indent="0">
+              <a:buNone/>
+              <a:defRPr sz="500"/>
             </a:lvl9pPr>
           </a:lstStyle>
           <a:p>
@@ -2209,7 +2209,7 @@
           <a:p>
             <a:fld id="{7AE4F870-186A-EB4F-9838-041FBD4EA0A4}" type="datetimeFigureOut">
               <a:rPr lang="en-US" smtClean="0"/>
-              <a:t>12/11/18</a:t>
+              <a:t>1/16/19</a:t>
             </a:fld>
             <a:endParaRPr lang="en-US"/>
           </a:p>
@@ -2266,7 +2266,7 @@
 </file>
 
 <file path=ppt/slideLayouts/slideLayout9.xml><?xml version="1.0" encoding="utf-8"?>
-<p:sldLayout xmlns:a="http://schemas.openxmlformats.org/drawingml/2006/main" xmlns:r="http://schemas.openxmlformats.org/officeDocument/2006/relationships" xmlns:mc="http://schemas.openxmlformats.org/markup-compatibility/2006" xmlns:mv="urn:schemas-microsoft-com:mac:vml" xmlns:p="http://schemas.openxmlformats.org/presentationml/2006/main" mc:Ignorable="mv" mc:PreserveAttributes="mv:*" type="picTx" preserve="1">
+<p:sldLayout xmlns:a="http://schemas.openxmlformats.org/drawingml/2006/main" xmlns:r="http://schemas.openxmlformats.org/officeDocument/2006/relationships" xmlns:p="http://schemas.openxmlformats.org/presentationml/2006/main" type="picTx" preserve="1">
   <p:cSld name="Picture with Caption">
     <p:spTree>
       <p:nvGrpSpPr>
@@ -2294,15 +2294,15 @@
         </p:nvSpPr>
         <p:spPr>
           <a:xfrm>
-            <a:off x="1792288" y="4800600"/>
-            <a:ext cx="5486400" cy="566738"/>
+            <a:off x="716915" y="2560323"/>
+            <a:ext cx="2194560" cy="302260"/>
           </a:xfrm>
         </p:spPr>
         <p:txBody>
           <a:bodyPr anchor="b"/>
           <a:lstStyle>
             <a:lvl1pPr algn="l">
-              <a:defRPr sz="2000" b="1"/>
+              <a:defRPr sz="1200" b="1"/>
             </a:lvl1pPr>
           </a:lstStyle>
           <a:p>
@@ -2326,8 +2326,8 @@
         </p:nvSpPr>
         <p:spPr>
           <a:xfrm>
-            <a:off x="1792288" y="612775"/>
-            <a:ext cx="5486400" cy="4114800"/>
+            <a:off x="716915" y="326815"/>
+            <a:ext cx="2194560" cy="2194560"/>
           </a:xfrm>
         </p:spPr>
         <p:txBody>
@@ -2335,39 +2335,39 @@
           <a:lstStyle>
             <a:lvl1pPr marL="0" indent="0">
               <a:buNone/>
-              <a:defRPr sz="3200"/>
+              <a:defRPr sz="1900"/>
             </a:lvl1pPr>
-            <a:lvl2pPr marL="457200" indent="0">
-              <a:buNone/>
-              <a:defRPr sz="2800"/>
+            <a:lvl2pPr marL="261227" indent="0">
+              <a:buNone/>
+              <a:defRPr sz="1700"/>
             </a:lvl2pPr>
-            <a:lvl3pPr marL="914400" indent="0">
-              <a:buNone/>
-              <a:defRPr sz="2400"/>
+            <a:lvl3pPr marL="522454" indent="0">
+              <a:buNone/>
+              <a:defRPr sz="1300"/>
             </a:lvl3pPr>
-            <a:lvl4pPr marL="1371600" indent="0">
-              <a:buNone/>
-              <a:defRPr sz="2000"/>
+            <a:lvl4pPr marL="783680" indent="0">
+              <a:buNone/>
+              <a:defRPr sz="1200"/>
             </a:lvl4pPr>
-            <a:lvl5pPr marL="1828800" indent="0">
-              <a:buNone/>
-              <a:defRPr sz="2000"/>
+            <a:lvl5pPr marL="1044909" indent="0">
+              <a:buNone/>
+              <a:defRPr sz="1200"/>
             </a:lvl5pPr>
-            <a:lvl6pPr marL="2286000" indent="0">
-              <a:buNone/>
-              <a:defRPr sz="2000"/>
+            <a:lvl6pPr marL="1306135" indent="0">
+              <a:buNone/>
+              <a:defRPr sz="1200"/>
             </a:lvl6pPr>
-            <a:lvl7pPr marL="2743200" indent="0">
-              <a:buNone/>
-              <a:defRPr sz="2000"/>
+            <a:lvl7pPr marL="1567362" indent="0">
+              <a:buNone/>
+              <a:defRPr sz="1200"/>
             </a:lvl7pPr>
-            <a:lvl8pPr marL="3200400" indent="0">
-              <a:buNone/>
-              <a:defRPr sz="2000"/>
+            <a:lvl8pPr marL="1828589" indent="0">
+              <a:buNone/>
+              <a:defRPr sz="1200"/>
             </a:lvl8pPr>
-            <a:lvl9pPr marL="3657600" indent="0">
-              <a:buNone/>
-              <a:defRPr sz="2000"/>
+            <a:lvl9pPr marL="2089818" indent="0">
+              <a:buNone/>
+              <a:defRPr sz="1200"/>
             </a:lvl9pPr>
           </a:lstStyle>
           <a:p>
@@ -2387,8 +2387,8 @@
         </p:nvSpPr>
         <p:spPr>
           <a:xfrm>
-            <a:off x="1792288" y="5367338"/>
-            <a:ext cx="5486400" cy="804862"/>
+            <a:off x="716915" y="2862583"/>
+            <a:ext cx="2194560" cy="429260"/>
           </a:xfrm>
         </p:spPr>
         <p:txBody>
@@ -2396,39 +2396,39 @@
           <a:lstStyle>
             <a:lvl1pPr marL="0" indent="0">
               <a:buNone/>
-              <a:defRPr sz="1400"/>
+              <a:defRPr sz="800"/>
             </a:lvl1pPr>
-            <a:lvl2pPr marL="457200" indent="0">
-              <a:buNone/>
-              <a:defRPr sz="1200"/>
+            <a:lvl2pPr marL="261227" indent="0">
+              <a:buNone/>
+              <a:defRPr sz="700"/>
             </a:lvl2pPr>
-            <a:lvl3pPr marL="914400" indent="0">
-              <a:buNone/>
-              <a:defRPr sz="1000"/>
+            <a:lvl3pPr marL="522454" indent="0">
+              <a:buNone/>
+              <a:defRPr sz="700"/>
             </a:lvl3pPr>
-            <a:lvl4pPr marL="1371600" indent="0">
-              <a:buNone/>
-              <a:defRPr sz="900"/>
+            <a:lvl4pPr marL="783680" indent="0">
+              <a:buNone/>
+              <a:defRPr sz="500"/>
             </a:lvl4pPr>
-            <a:lvl5pPr marL="1828800" indent="0">
-              <a:buNone/>
-              <a:defRPr sz="900"/>
+            <a:lvl5pPr marL="1044909" indent="0">
+              <a:buNone/>
+              <a:defRPr sz="500"/>
             </a:lvl5pPr>
-            <a:lvl6pPr marL="2286000" indent="0">
-              <a:buNone/>
-              <a:defRPr sz="900"/>
+            <a:lvl6pPr marL="1306135" indent="0">
+              <a:buNone/>
+              <a:defRPr sz="500"/>
             </a:lvl6pPr>
-            <a:lvl7pPr marL="2743200" indent="0">
-              <a:buNone/>
-              <a:defRPr sz="900"/>
+            <a:lvl7pPr marL="1567362" indent="0">
+              <a:buNone/>
+              <a:defRPr sz="500"/>
             </a:lvl7pPr>
-            <a:lvl8pPr marL="3200400" indent="0">
-              <a:buNone/>
-              <a:defRPr sz="900"/>
+            <a:lvl8pPr marL="1828589" indent="0">
+              <a:buNone/>
+              <a:defRPr sz="500"/>
             </a:lvl8pPr>
-            <a:lvl9pPr marL="3657600" indent="0">
-              <a:buNone/>
-              <a:defRPr sz="900"/>
+            <a:lvl9pPr marL="2089818" indent="0">
+              <a:buNone/>
+              <a:defRPr sz="500"/>
             </a:lvl9pPr>
           </a:lstStyle>
           <a:p>
@@ -2457,7 +2457,7 @@
           <a:p>
             <a:fld id="{7AE4F870-186A-EB4F-9838-041FBD4EA0A4}" type="datetimeFigureOut">
               <a:rPr lang="en-US" smtClean="0"/>
-              <a:t>12/11/18</a:t>
+              <a:t>1/16/19</a:t>
             </a:fld>
             <a:endParaRPr lang="en-US"/>
           </a:p>
@@ -2514,7 +2514,7 @@
 </file>
 
 <file path=ppt/slideMasters/slideMaster1.xml><?xml version="1.0" encoding="utf-8"?>
-<p:sldMaster xmlns:a="http://schemas.openxmlformats.org/drawingml/2006/main" xmlns:r="http://schemas.openxmlformats.org/officeDocument/2006/relationships" xmlns:mc="http://schemas.openxmlformats.org/markup-compatibility/2006" xmlns:mv="urn:schemas-microsoft-com:mac:vml" xmlns:p="http://schemas.openxmlformats.org/presentationml/2006/main" mc:Ignorable="mv" mc:PreserveAttributes="mv:*">
+<p:sldMaster xmlns:a="http://schemas.openxmlformats.org/drawingml/2006/main" xmlns:r="http://schemas.openxmlformats.org/officeDocument/2006/relationships" xmlns:p="http://schemas.openxmlformats.org/presentationml/2006/main">
   <p:cSld>
     <p:bg>
       <p:bgRef idx="1001">
@@ -2547,15 +2547,15 @@
         </p:nvSpPr>
         <p:spPr>
           <a:xfrm>
-            <a:off x="457200" y="274638"/>
-            <a:ext cx="8229600" cy="1143000"/>
+            <a:off x="182880" y="146475"/>
+            <a:ext cx="3291840" cy="609600"/>
           </a:xfrm>
           <a:prstGeom prst="rect">
             <a:avLst/>
           </a:prstGeom>
         </p:spPr>
         <p:txBody>
-          <a:bodyPr vert="horz" lIns="91440" tIns="45720" rIns="91440" bIns="45720" rtlCol="0" anchor="ctr">
+          <a:bodyPr vert="horz" lIns="52245" tIns="26122" rIns="52245" bIns="26122" rtlCol="0" anchor="ctr">
             <a:normAutofit/>
           </a:bodyPr>
           <a:lstStyle/>
@@ -2580,15 +2580,15 @@
         </p:nvSpPr>
         <p:spPr>
           <a:xfrm>
-            <a:off x="457200" y="1600200"/>
-            <a:ext cx="8229600" cy="4525963"/>
+            <a:off x="182880" y="853443"/>
+            <a:ext cx="3291840" cy="2413847"/>
           </a:xfrm>
           <a:prstGeom prst="rect">
             <a:avLst/>
           </a:prstGeom>
         </p:spPr>
         <p:txBody>
-          <a:bodyPr vert="horz" lIns="91440" tIns="45720" rIns="91440" bIns="45720" rtlCol="0">
+          <a:bodyPr vert="horz" lIns="52245" tIns="26122" rIns="52245" bIns="26122" rtlCol="0">
             <a:normAutofit/>
           </a:bodyPr>
           <a:lstStyle/>
@@ -2642,18 +2642,18 @@
         </p:nvSpPr>
         <p:spPr>
           <a:xfrm>
-            <a:off x="457200" y="6356350"/>
-            <a:ext cx="2133600" cy="365125"/>
+            <a:off x="182880" y="3390055"/>
+            <a:ext cx="853440" cy="194735"/>
           </a:xfrm>
           <a:prstGeom prst="rect">
             <a:avLst/>
           </a:prstGeom>
         </p:spPr>
         <p:txBody>
-          <a:bodyPr vert="horz" lIns="91440" tIns="45720" rIns="91440" bIns="45720" rtlCol="0" anchor="ctr"/>
+          <a:bodyPr vert="horz" lIns="52245" tIns="26122" rIns="52245" bIns="26122" rtlCol="0" anchor="ctr"/>
           <a:lstStyle>
             <a:lvl1pPr algn="l">
-              <a:defRPr sz="1200">
+              <a:defRPr sz="700">
                 <a:solidFill>
                   <a:schemeClr val="tx1">
                     <a:tint val="75000"/>
@@ -2665,7 +2665,7 @@
           <a:p>
             <a:fld id="{7AE4F870-186A-EB4F-9838-041FBD4EA0A4}" type="datetimeFigureOut">
               <a:rPr lang="en-US" smtClean="0"/>
-              <a:t>12/11/18</a:t>
+              <a:t>1/16/19</a:t>
             </a:fld>
             <a:endParaRPr lang="en-US"/>
           </a:p>
@@ -2683,18 +2683,18 @@
         </p:nvSpPr>
         <p:spPr>
           <a:xfrm>
-            <a:off x="3124200" y="6356350"/>
-            <a:ext cx="2895600" cy="365125"/>
+            <a:off x="1249680" y="3390055"/>
+            <a:ext cx="1158240" cy="194735"/>
           </a:xfrm>
           <a:prstGeom prst="rect">
             <a:avLst/>
           </a:prstGeom>
         </p:spPr>
         <p:txBody>
-          <a:bodyPr vert="horz" lIns="91440" tIns="45720" rIns="91440" bIns="45720" rtlCol="0" anchor="ctr"/>
+          <a:bodyPr vert="horz" lIns="52245" tIns="26122" rIns="52245" bIns="26122" rtlCol="0" anchor="ctr"/>
           <a:lstStyle>
             <a:lvl1pPr algn="ctr">
-              <a:defRPr sz="1200">
+              <a:defRPr sz="700">
                 <a:solidFill>
                   <a:schemeClr val="tx1">
                     <a:tint val="75000"/>
@@ -2720,18 +2720,18 @@
         </p:nvSpPr>
         <p:spPr>
           <a:xfrm>
-            <a:off x="6553200" y="6356350"/>
-            <a:ext cx="2133600" cy="365125"/>
+            <a:off x="2621280" y="3390055"/>
+            <a:ext cx="853440" cy="194735"/>
           </a:xfrm>
           <a:prstGeom prst="rect">
             <a:avLst/>
           </a:prstGeom>
         </p:spPr>
         <p:txBody>
-          <a:bodyPr vert="horz" lIns="91440" tIns="45720" rIns="91440" bIns="45720" rtlCol="0" anchor="ctr"/>
+          <a:bodyPr vert="horz" lIns="52245" tIns="26122" rIns="52245" bIns="26122" rtlCol="0" anchor="ctr"/>
           <a:lstStyle>
             <a:lvl1pPr algn="r">
-              <a:defRPr sz="1200">
+              <a:defRPr sz="700">
                 <a:solidFill>
                   <a:schemeClr val="tx1">
                     <a:tint val="75000"/>
@@ -2767,12 +2767,12 @@
   </p:sldLayoutIdLst>
   <p:txStyles>
     <p:titleStyle>
-      <a:lvl1pPr algn="ctr" defTabSz="457200" rtl="0" eaLnBrk="1" latinLnBrk="0" hangingPunct="1">
+      <a:lvl1pPr algn="ctr" defTabSz="261227" rtl="0" eaLnBrk="1" latinLnBrk="0" hangingPunct="1">
         <a:spcBef>
           <a:spcPct val="0"/>
         </a:spcBef>
         <a:buNone/>
-        <a:defRPr sz="4400" kern="1200">
+        <a:defRPr sz="2500" kern="1200">
           <a:solidFill>
             <a:schemeClr val="tx1"/>
           </a:solidFill>
@@ -2783,13 +2783,13 @@
       </a:lvl1pPr>
     </p:titleStyle>
     <p:bodyStyle>
-      <a:lvl1pPr marL="342900" indent="-342900" algn="l" defTabSz="457200" rtl="0" eaLnBrk="1" latinLnBrk="0" hangingPunct="1">
+      <a:lvl1pPr marL="195920" indent="-195920" algn="l" defTabSz="261227" rtl="0" eaLnBrk="1" latinLnBrk="0" hangingPunct="1">
         <a:spcBef>
           <a:spcPct val="20000"/>
         </a:spcBef>
         <a:buFont typeface="Arial"/>
         <a:buChar char="•"/>
-        <a:defRPr sz="3200" kern="1200">
+        <a:defRPr sz="1900" kern="1200">
           <a:solidFill>
             <a:schemeClr val="tx1"/>
           </a:solidFill>
@@ -2798,13 +2798,13 @@
           <a:cs typeface="+mn-cs"/>
         </a:defRPr>
       </a:lvl1pPr>
-      <a:lvl2pPr marL="742950" indent="-285750" algn="l" defTabSz="457200" rtl="0" eaLnBrk="1" latinLnBrk="0" hangingPunct="1">
+      <a:lvl2pPr marL="424495" indent="-163268" algn="l" defTabSz="261227" rtl="0" eaLnBrk="1" latinLnBrk="0" hangingPunct="1">
         <a:spcBef>
           <a:spcPct val="20000"/>
         </a:spcBef>
         <a:buFont typeface="Arial"/>
         <a:buChar char="–"/>
-        <a:defRPr sz="2800" kern="1200">
+        <a:defRPr sz="1700" kern="1200">
           <a:solidFill>
             <a:schemeClr val="tx1"/>
           </a:solidFill>
@@ -2813,13 +2813,13 @@
           <a:cs typeface="+mn-cs"/>
         </a:defRPr>
       </a:lvl2pPr>
-      <a:lvl3pPr marL="1143000" indent="-228600" algn="l" defTabSz="457200" rtl="0" eaLnBrk="1" latinLnBrk="0" hangingPunct="1">
+      <a:lvl3pPr marL="653068" indent="-130613" algn="l" defTabSz="261227" rtl="0" eaLnBrk="1" latinLnBrk="0" hangingPunct="1">
         <a:spcBef>
           <a:spcPct val="20000"/>
         </a:spcBef>
         <a:buFont typeface="Arial"/>
         <a:buChar char="•"/>
-        <a:defRPr sz="2400" kern="1200">
+        <a:defRPr sz="1300" kern="1200">
           <a:solidFill>
             <a:schemeClr val="tx1"/>
           </a:solidFill>
@@ -2828,13 +2828,13 @@
           <a:cs typeface="+mn-cs"/>
         </a:defRPr>
       </a:lvl3pPr>
-      <a:lvl4pPr marL="1600200" indent="-228600" algn="l" defTabSz="457200" rtl="0" eaLnBrk="1" latinLnBrk="0" hangingPunct="1">
+      <a:lvl4pPr marL="914294" indent="-130613" algn="l" defTabSz="261227" rtl="0" eaLnBrk="1" latinLnBrk="0" hangingPunct="1">
         <a:spcBef>
           <a:spcPct val="20000"/>
         </a:spcBef>
         <a:buFont typeface="Arial"/>
         <a:buChar char="–"/>
-        <a:defRPr sz="2000" kern="1200">
+        <a:defRPr sz="1200" kern="1200">
           <a:solidFill>
             <a:schemeClr val="tx1"/>
           </a:solidFill>
@@ -2843,13 +2843,13 @@
           <a:cs typeface="+mn-cs"/>
         </a:defRPr>
       </a:lvl4pPr>
-      <a:lvl5pPr marL="2057400" indent="-228600" algn="l" defTabSz="457200" rtl="0" eaLnBrk="1" latinLnBrk="0" hangingPunct="1">
+      <a:lvl5pPr marL="1175521" indent="-130613" algn="l" defTabSz="261227" rtl="0" eaLnBrk="1" latinLnBrk="0" hangingPunct="1">
         <a:spcBef>
           <a:spcPct val="20000"/>
         </a:spcBef>
         <a:buFont typeface="Arial"/>
         <a:buChar char="»"/>
-        <a:defRPr sz="2000" kern="1200">
+        <a:defRPr sz="1200" kern="1200">
           <a:solidFill>
             <a:schemeClr val="tx1"/>
           </a:solidFill>
@@ -2858,13 +2858,13 @@
           <a:cs typeface="+mn-cs"/>
         </a:defRPr>
       </a:lvl5pPr>
-      <a:lvl6pPr marL="2514600" indent="-228600" algn="l" defTabSz="457200" rtl="0" eaLnBrk="1" latinLnBrk="0" hangingPunct="1">
+      <a:lvl6pPr marL="1436748" indent="-130613" algn="l" defTabSz="261227" rtl="0" eaLnBrk="1" latinLnBrk="0" hangingPunct="1">
         <a:spcBef>
           <a:spcPct val="20000"/>
         </a:spcBef>
         <a:buFont typeface="Arial"/>
         <a:buChar char="•"/>
-        <a:defRPr sz="2000" kern="1200">
+        <a:defRPr sz="1200" kern="1200">
           <a:solidFill>
             <a:schemeClr val="tx1"/>
           </a:solidFill>
@@ -2873,13 +2873,13 @@
           <a:cs typeface="+mn-cs"/>
         </a:defRPr>
       </a:lvl6pPr>
-      <a:lvl7pPr marL="2971800" indent="-228600" algn="l" defTabSz="457200" rtl="0" eaLnBrk="1" latinLnBrk="0" hangingPunct="1">
+      <a:lvl7pPr marL="1697976" indent="-130613" algn="l" defTabSz="261227" rtl="0" eaLnBrk="1" latinLnBrk="0" hangingPunct="1">
         <a:spcBef>
           <a:spcPct val="20000"/>
         </a:spcBef>
         <a:buFont typeface="Arial"/>
         <a:buChar char="•"/>
-        <a:defRPr sz="2000" kern="1200">
+        <a:defRPr sz="1200" kern="1200">
           <a:solidFill>
             <a:schemeClr val="tx1"/>
           </a:solidFill>
@@ -2888,13 +2888,13 @@
           <a:cs typeface="+mn-cs"/>
         </a:defRPr>
       </a:lvl7pPr>
-      <a:lvl8pPr marL="3429000" indent="-228600" algn="l" defTabSz="457200" rtl="0" eaLnBrk="1" latinLnBrk="0" hangingPunct="1">
+      <a:lvl8pPr marL="1959204" indent="-130613" algn="l" defTabSz="261227" rtl="0" eaLnBrk="1" latinLnBrk="0" hangingPunct="1">
         <a:spcBef>
           <a:spcPct val="20000"/>
         </a:spcBef>
         <a:buFont typeface="Arial"/>
         <a:buChar char="•"/>
-        <a:defRPr sz="2000" kern="1200">
+        <a:defRPr sz="1200" kern="1200">
           <a:solidFill>
             <a:schemeClr val="tx1"/>
           </a:solidFill>
@@ -2903,13 +2903,13 @@
           <a:cs typeface="+mn-cs"/>
         </a:defRPr>
       </a:lvl8pPr>
-      <a:lvl9pPr marL="3886200" indent="-228600" algn="l" defTabSz="457200" rtl="0" eaLnBrk="1" latinLnBrk="0" hangingPunct="1">
+      <a:lvl9pPr marL="2220431" indent="-130613" algn="l" defTabSz="261227" rtl="0" eaLnBrk="1" latinLnBrk="0" hangingPunct="1">
         <a:spcBef>
           <a:spcPct val="20000"/>
         </a:spcBef>
         <a:buFont typeface="Arial"/>
         <a:buChar char="•"/>
-        <a:defRPr sz="2000" kern="1200">
+        <a:defRPr sz="1200" kern="1200">
           <a:solidFill>
             <a:schemeClr val="tx1"/>
           </a:solidFill>
@@ -2923,8 +2923,8 @@
       <a:defPPr>
         <a:defRPr lang="en-US"/>
       </a:defPPr>
-      <a:lvl1pPr marL="0" algn="l" defTabSz="457200" rtl="0" eaLnBrk="1" latinLnBrk="0" hangingPunct="1">
-        <a:defRPr sz="1800" kern="1200">
+      <a:lvl1pPr marL="0" algn="l" defTabSz="261227" rtl="0" eaLnBrk="1" latinLnBrk="0" hangingPunct="1">
+        <a:defRPr sz="1100" kern="1200">
           <a:solidFill>
             <a:schemeClr val="tx1"/>
           </a:solidFill>
@@ -2933,8 +2933,8 @@
           <a:cs typeface="+mn-cs"/>
         </a:defRPr>
       </a:lvl1pPr>
-      <a:lvl2pPr marL="457200" algn="l" defTabSz="457200" rtl="0" eaLnBrk="1" latinLnBrk="0" hangingPunct="1">
-        <a:defRPr sz="1800" kern="1200">
+      <a:lvl2pPr marL="261227" algn="l" defTabSz="261227" rtl="0" eaLnBrk="1" latinLnBrk="0" hangingPunct="1">
+        <a:defRPr sz="1100" kern="1200">
           <a:solidFill>
             <a:schemeClr val="tx1"/>
           </a:solidFill>
@@ -2943,8 +2943,8 @@
           <a:cs typeface="+mn-cs"/>
         </a:defRPr>
       </a:lvl2pPr>
-      <a:lvl3pPr marL="914400" algn="l" defTabSz="457200" rtl="0" eaLnBrk="1" latinLnBrk="0" hangingPunct="1">
-        <a:defRPr sz="1800" kern="1200">
+      <a:lvl3pPr marL="522454" algn="l" defTabSz="261227" rtl="0" eaLnBrk="1" latinLnBrk="0" hangingPunct="1">
+        <a:defRPr sz="1100" kern="1200">
           <a:solidFill>
             <a:schemeClr val="tx1"/>
           </a:solidFill>
@@ -2953,8 +2953,8 @@
           <a:cs typeface="+mn-cs"/>
         </a:defRPr>
       </a:lvl3pPr>
-      <a:lvl4pPr marL="1371600" algn="l" defTabSz="457200" rtl="0" eaLnBrk="1" latinLnBrk="0" hangingPunct="1">
-        <a:defRPr sz="1800" kern="1200">
+      <a:lvl4pPr marL="783680" algn="l" defTabSz="261227" rtl="0" eaLnBrk="1" latinLnBrk="0" hangingPunct="1">
+        <a:defRPr sz="1100" kern="1200">
           <a:solidFill>
             <a:schemeClr val="tx1"/>
           </a:solidFill>
@@ -2963,8 +2963,8 @@
           <a:cs typeface="+mn-cs"/>
         </a:defRPr>
       </a:lvl4pPr>
-      <a:lvl5pPr marL="1828800" algn="l" defTabSz="457200" rtl="0" eaLnBrk="1" latinLnBrk="0" hangingPunct="1">
-        <a:defRPr sz="1800" kern="1200">
+      <a:lvl5pPr marL="1044909" algn="l" defTabSz="261227" rtl="0" eaLnBrk="1" latinLnBrk="0" hangingPunct="1">
+        <a:defRPr sz="1100" kern="1200">
           <a:solidFill>
             <a:schemeClr val="tx1"/>
           </a:solidFill>
@@ -2973,8 +2973,8 @@
           <a:cs typeface="+mn-cs"/>
         </a:defRPr>
       </a:lvl5pPr>
-      <a:lvl6pPr marL="2286000" algn="l" defTabSz="457200" rtl="0" eaLnBrk="1" latinLnBrk="0" hangingPunct="1">
-        <a:defRPr sz="1800" kern="1200">
+      <a:lvl6pPr marL="1306135" algn="l" defTabSz="261227" rtl="0" eaLnBrk="1" latinLnBrk="0" hangingPunct="1">
+        <a:defRPr sz="1100" kern="1200">
           <a:solidFill>
             <a:schemeClr val="tx1"/>
           </a:solidFill>
@@ -2983,8 +2983,8 @@
           <a:cs typeface="+mn-cs"/>
         </a:defRPr>
       </a:lvl6pPr>
-      <a:lvl7pPr marL="2743200" algn="l" defTabSz="457200" rtl="0" eaLnBrk="1" latinLnBrk="0" hangingPunct="1">
-        <a:defRPr sz="1800" kern="1200">
+      <a:lvl7pPr marL="1567362" algn="l" defTabSz="261227" rtl="0" eaLnBrk="1" latinLnBrk="0" hangingPunct="1">
+        <a:defRPr sz="1100" kern="1200">
           <a:solidFill>
             <a:schemeClr val="tx1"/>
           </a:solidFill>
@@ -2993,8 +2993,8 @@
           <a:cs typeface="+mn-cs"/>
         </a:defRPr>
       </a:lvl7pPr>
-      <a:lvl8pPr marL="3200400" algn="l" defTabSz="457200" rtl="0" eaLnBrk="1" latinLnBrk="0" hangingPunct="1">
-        <a:defRPr sz="1800" kern="1200">
+      <a:lvl8pPr marL="1828589" algn="l" defTabSz="261227" rtl="0" eaLnBrk="1" latinLnBrk="0" hangingPunct="1">
+        <a:defRPr sz="1100" kern="1200">
           <a:solidFill>
             <a:schemeClr val="tx1"/>
           </a:solidFill>
@@ -3003,8 +3003,8 @@
           <a:cs typeface="+mn-cs"/>
         </a:defRPr>
       </a:lvl8pPr>
-      <a:lvl9pPr marL="3657600" algn="l" defTabSz="457200" rtl="0" eaLnBrk="1" latinLnBrk="0" hangingPunct="1">
-        <a:defRPr sz="1800" kern="1200">
+      <a:lvl9pPr marL="2089818" algn="l" defTabSz="261227" rtl="0" eaLnBrk="1" latinLnBrk="0" hangingPunct="1">
+        <a:defRPr sz="1100" kern="1200">
           <a:solidFill>
             <a:schemeClr val="tx1"/>
           </a:solidFill>
@@ -3019,7 +3019,7 @@
 </file>
 
 <file path=ppt/slides/slide1.xml><?xml version="1.0" encoding="utf-8"?>
-<p:sld xmlns:a="http://schemas.openxmlformats.org/drawingml/2006/main" xmlns:r="http://schemas.openxmlformats.org/officeDocument/2006/relationships" xmlns:mc="http://schemas.openxmlformats.org/markup-compatibility/2006" xmlns:mv="urn:schemas-microsoft-com:mac:vml" xmlns:p="http://schemas.openxmlformats.org/presentationml/2006/main" mc:Ignorable="mv" mc:PreserveAttributes="mv:*">
+<p:sld xmlns:a="http://schemas.openxmlformats.org/drawingml/2006/main" xmlns:r="http://schemas.openxmlformats.org/officeDocument/2006/relationships" xmlns:p="http://schemas.openxmlformats.org/presentationml/2006/main">
   <p:cSld>
     <p:spTree>
       <p:nvGrpSpPr>
@@ -3043,8 +3043,8 @@
         </p:nvSpPr>
         <p:spPr>
           <a:xfrm>
-            <a:off x="1445172" y="245417"/>
-            <a:ext cx="1000234" cy="822960"/>
+            <a:off x="743637" y="327671"/>
+            <a:ext cx="826696" cy="762804"/>
           </a:xfrm>
           <a:prstGeom prst="roundRect">
             <a:avLst/>
@@ -3066,19 +3066,19 @@
           </a:fontRef>
         </p:style>
         <p:txBody>
-          <a:bodyPr anchor="ctr"/>
+          <a:bodyPr lIns="52245" tIns="26122" rIns="52245" bIns="26122" anchor="ctr"/>
           <a:lstStyle/>
           <a:p>
             <a:pPr algn="ctr"/>
             <a:r>
-              <a:rPr lang="en-US" sz="1200" dirty="0" smtClean="0"/>
-              <a:t>Plink</a:t>
+              <a:rPr lang="en-US" sz="1200" dirty="0"/>
+              <a:t>PLINK</a:t>
             </a:r>
           </a:p>
           <a:p>
             <a:pPr algn="ctr"/>
             <a:r>
-              <a:rPr lang="en-US" sz="1200" dirty="0" smtClean="0"/>
+              <a:rPr lang="en-US" sz="1200" dirty="0"/>
               <a:t> Data</a:t>
             </a:r>
             <a:endParaRPr lang="en-US" sz="1200" dirty="0"/>
@@ -3093,8 +3093,8 @@
         </p:nvSpPr>
         <p:spPr>
           <a:xfrm>
-            <a:off x="3004380" y="271692"/>
-            <a:ext cx="1033343" cy="822960"/>
+            <a:off x="1929942" y="330041"/>
+            <a:ext cx="854062" cy="762804"/>
           </a:xfrm>
           <a:prstGeom prst="roundRect">
             <a:avLst/>
@@ -3116,12 +3116,12 @@
           </a:fontRef>
         </p:style>
         <p:txBody>
-          <a:bodyPr anchor="ctr"/>
+          <a:bodyPr lIns="52245" tIns="26122" rIns="52245" bIns="26122" anchor="ctr"/>
           <a:lstStyle/>
           <a:p>
             <a:pPr algn="ctr"/>
             <a:r>
-              <a:rPr lang="en-US" sz="1200" dirty="0" smtClean="0"/>
+              <a:rPr lang="en-US" sz="1200" dirty="0"/>
               <a:t>Mega2</a:t>
             </a:r>
             <a:endParaRPr lang="en-US" sz="1200" dirty="0"/>
@@ -3136,8 +3136,8 @@
         </p:nvSpPr>
         <p:spPr>
           <a:xfrm>
-            <a:off x="3004381" y="1646796"/>
-            <a:ext cx="1033342" cy="822960"/>
+            <a:off x="1929944" y="1514653"/>
+            <a:ext cx="854062" cy="762804"/>
           </a:xfrm>
           <a:prstGeom prst="roundRect">
             <a:avLst/>
@@ -3159,12 +3159,12 @@
           </a:fontRef>
         </p:style>
         <p:txBody>
-          <a:bodyPr anchor="ctr"/>
+          <a:bodyPr lIns="52245" tIns="26122" rIns="52245" bIns="26122" anchor="ctr"/>
           <a:lstStyle/>
           <a:p>
             <a:pPr algn="ctr"/>
             <a:r>
-              <a:rPr lang="en-US" sz="1200" dirty="0" smtClean="0"/>
+              <a:rPr lang="en-US" sz="1200" dirty="0"/>
               <a:t>Mega2R</a:t>
             </a:r>
             <a:endParaRPr lang="en-US" sz="1200" dirty="0"/>
@@ -3179,8 +3179,8 @@
         </p:nvSpPr>
         <p:spPr>
           <a:xfrm>
-            <a:off x="3004381" y="2763430"/>
-            <a:ext cx="1033342" cy="779343"/>
+            <a:off x="1857587" y="2582352"/>
+            <a:ext cx="995840" cy="722375"/>
           </a:xfrm>
           <a:prstGeom prst="roundRect">
             <a:avLst/>
@@ -3202,15 +3202,15 @@
           </a:fontRef>
         </p:style>
         <p:txBody>
-          <a:bodyPr anchor="ctr"/>
+          <a:bodyPr lIns="52245" tIns="26122" rIns="52245" bIns="26122" anchor="ctr"/>
           <a:lstStyle/>
           <a:p>
             <a:pPr algn="ctr"/>
             <a:r>
-              <a:rPr lang="en-US" sz="1200" dirty="0" err="1" smtClean="0"/>
+              <a:rPr lang="en-US" sz="1200" dirty="0" err="1"/>
               <a:t>Dataframes</a:t>
             </a:r>
-            <a:endParaRPr lang="en-US" sz="1200" dirty="0" smtClean="0"/>
+            <a:endParaRPr lang="en-US" sz="1200" dirty="0"/>
           </a:p>
         </p:txBody>
       </p:sp>
@@ -3222,8 +3222,8 @@
         </p:nvSpPr>
         <p:spPr>
           <a:xfrm>
-            <a:off x="1445172" y="1646796"/>
-            <a:ext cx="1000234" cy="822960"/>
+            <a:off x="743640" y="1516465"/>
+            <a:ext cx="826696" cy="762804"/>
           </a:xfrm>
           <a:prstGeom prst="flowChartMagneticDisk">
             <a:avLst/>
@@ -3245,75 +3245,19 @@
           </a:fontRef>
         </p:style>
         <p:txBody>
-          <a:bodyPr anchor="ctr"/>
+          <a:bodyPr lIns="52245" tIns="26122" rIns="52245" bIns="26122" anchor="ctr"/>
           <a:lstStyle/>
           <a:p>
             <a:pPr algn="ctr"/>
             <a:r>
-              <a:rPr lang="en-US" sz="1200" dirty="0" smtClean="0"/>
-              <a:t>SQLite3 Database</a:t>
+              <a:rPr lang="en-US" sz="1200" smtClean="0"/>
+              <a:t>SQLite </a:t>
+            </a:r>
+            <a:r>
+              <a:rPr lang="en-US" sz="1200" dirty="0"/>
+              <a:t>Database</a:t>
             </a:r>
             <a:endParaRPr lang="en-US" sz="1200" dirty="0"/>
-          </a:p>
-        </p:txBody>
-      </p:sp>
-      <p:sp>
-        <p:nvSpPr>
-          <p:cNvPr id="29" name="TextBox 28"/>
-          <p:cNvSpPr txBox="1"/>
-          <p:nvPr/>
-        </p:nvSpPr>
-        <p:spPr>
-          <a:xfrm>
-            <a:off x="1488089" y="3861082"/>
-            <a:ext cx="3434256" cy="369332"/>
-          </a:xfrm>
-          <a:prstGeom prst="rect">
-            <a:avLst/>
-          </a:prstGeom>
-          <a:noFill/>
-        </p:spPr>
-        <p:txBody>
-          <a:bodyPr wrap="square" rtlCol="0">
-            <a:spAutoFit/>
-          </a:bodyPr>
-          <a:lstStyle/>
-          <a:p>
-            <a:r>
-              <a:rPr lang="en-US" dirty="0" smtClean="0"/>
-              <a:t>Example conversion of data to R.</a:t>
-            </a:r>
-            <a:endParaRPr lang="en-US" dirty="0"/>
-          </a:p>
-        </p:txBody>
-      </p:sp>
-      <p:sp>
-        <p:nvSpPr>
-          <p:cNvPr id="30" name="TextBox 29"/>
-          <p:cNvSpPr txBox="1"/>
-          <p:nvPr/>
-        </p:nvSpPr>
-        <p:spPr>
-          <a:xfrm>
-            <a:off x="1445172" y="4276580"/>
-            <a:ext cx="6438463" cy="646331"/>
-          </a:xfrm>
-          <a:prstGeom prst="rect">
-            <a:avLst/>
-          </a:prstGeom>
-          <a:noFill/>
-        </p:spPr>
-        <p:txBody>
-          <a:bodyPr wrap="square" rtlCol="0">
-            <a:spAutoFit/>
-          </a:bodyPr>
-          <a:lstStyle/>
-          <a:p>
-            <a:r>
-              <a:rPr lang="en-US" dirty="0" smtClean="0"/>
-              <a:t>Convert data formats via a Mega2 created database into R data frames.  These data can be easily used in other R packages.</a:t>
-            </a:r>
-            <a:endParaRPr lang="en-US" dirty="0"/>
           </a:p>
         </p:txBody>
       </p:sp>
@@ -3322,13 +3266,14 @@
           <p:cNvPr id="32" name="Straight Arrow Connector 31"/>
           <p:cNvCxnSpPr>
             <a:stCxn id="4" idx="3"/>
+            <a:endCxn id="6" idx="1"/>
           </p:cNvCxnSpPr>
           <p:nvPr/>
         </p:nvCxnSpPr>
         <p:spPr>
-          <a:xfrm flipV="1">
-            <a:off x="2445406" y="639379"/>
-            <a:ext cx="558974" cy="17518"/>
+          <a:xfrm>
+            <a:off x="1570333" y="709073"/>
+            <a:ext cx="359609" cy="2370"/>
           </a:xfrm>
           <a:prstGeom prst="straightConnector1">
             <a:avLst/>
@@ -3363,8 +3308,8 @@
         </p:nvCxnSpPr>
         <p:spPr>
           <a:xfrm rot="5400000">
-            <a:off x="2457099" y="582843"/>
-            <a:ext cx="552144" cy="1575763"/>
+            <a:off x="1545171" y="704663"/>
+            <a:ext cx="423620" cy="1199985"/>
           </a:xfrm>
           <a:prstGeom prst="bentConnector3">
             <a:avLst>
@@ -3400,9 +3345,9 @@
           <p:nvPr/>
         </p:nvCxnSpPr>
         <p:spPr>
-          <a:xfrm>
-            <a:off x="2445406" y="2058276"/>
-            <a:ext cx="558975" cy="1588"/>
+          <a:xfrm flipV="1">
+            <a:off x="1570336" y="1896055"/>
+            <a:ext cx="359608" cy="1812"/>
           </a:xfrm>
           <a:prstGeom prst="straightConnector1">
             <a:avLst/>
@@ -3436,9 +3381,9 @@
           <p:nvPr/>
         </p:nvCxnSpPr>
         <p:spPr>
-          <a:xfrm rot="5400000">
-            <a:off x="3374215" y="2616593"/>
-            <a:ext cx="293674" cy="1588"/>
+          <a:xfrm flipH="1">
+            <a:off x="2355507" y="2277457"/>
+            <a:ext cx="1468" cy="304895"/>
           </a:xfrm>
           <a:prstGeom prst="straightConnector1">
             <a:avLst/>
@@ -3470,7 +3415,7 @@
   <p:timing>
     <p:tnLst>
       <p:par>
-        <p:cTn id="1" dur="indefinite" restart="never" nodeType="tmRoot"/>
+        <p:cTn xmlns:p14="http://schemas.microsoft.com/office/powerpoint/2010/main" id="1" dur="indefinite" restart="never" nodeType="tmRoot"/>
       </p:par>
     </p:tnLst>
   </p:timing>

</xml_diff>